<commit_message>
updated slides for class
</commit_message>
<xml_diff>
--- a/slides/brc_hazel_week_d3.pptx
+++ b/slides/brc_hazel_week_d3.pptx
@@ -5,25 +5,24 @@
     <p:sldMasterId id="2147483648" r:id="rId1"/>
   </p:sldMasterIdLst>
   <p:notesMasterIdLst>
-    <p:notesMasterId r:id="rId18"/>
+    <p:notesMasterId r:id="rId17"/>
   </p:notesMasterIdLst>
   <p:sldIdLst>
     <p:sldId id="257" r:id="rId2"/>
     <p:sldId id="258" r:id="rId3"/>
-    <p:sldId id="301" r:id="rId4"/>
-    <p:sldId id="260" r:id="rId5"/>
-    <p:sldId id="271" r:id="rId6"/>
-    <p:sldId id="307" r:id="rId7"/>
-    <p:sldId id="309" r:id="rId8"/>
-    <p:sldId id="311" r:id="rId9"/>
-    <p:sldId id="312" r:id="rId10"/>
-    <p:sldId id="310" r:id="rId11"/>
-    <p:sldId id="302" r:id="rId12"/>
-    <p:sldId id="305" r:id="rId13"/>
-    <p:sldId id="303" r:id="rId14"/>
-    <p:sldId id="304" r:id="rId15"/>
-    <p:sldId id="313" r:id="rId16"/>
-    <p:sldId id="314" r:id="rId17"/>
+    <p:sldId id="260" r:id="rId4"/>
+    <p:sldId id="271" r:id="rId5"/>
+    <p:sldId id="307" r:id="rId6"/>
+    <p:sldId id="309" r:id="rId7"/>
+    <p:sldId id="311" r:id="rId8"/>
+    <p:sldId id="312" r:id="rId9"/>
+    <p:sldId id="310" r:id="rId10"/>
+    <p:sldId id="302" r:id="rId11"/>
+    <p:sldId id="305" r:id="rId12"/>
+    <p:sldId id="303" r:id="rId13"/>
+    <p:sldId id="304" r:id="rId14"/>
+    <p:sldId id="313" r:id="rId15"/>
+    <p:sldId id="314" r:id="rId16"/>
   </p:sldIdLst>
   <p:sldSz cx="12192000" cy="6858000"/>
   <p:notesSz cx="6858000" cy="9144000"/>
@@ -212,7 +211,7 @@
           <a:p>
             <a:fld id="{984471E7-7CE5-9D40-BD1B-52AB22D8FAB0}" type="datetimeFigureOut">
               <a:rPr lang="en-US" smtClean="0"/>
-              <a:t>5/12/26</a:t>
+              <a:t>5/13/26</a:t>
             </a:fld>
             <a:endParaRPr lang="en-US"/>
           </a:p>
@@ -652,7 +651,7 @@
           <a:p>
             <a:fld id="{13FC26C8-C37B-D543-9AB9-4FE91B5DFE38}" type="slidenum">
               <a:rPr lang="en-US" smtClean="0"/>
-              <a:t>15</a:t>
+              <a:t>14</a:t>
             </a:fld>
             <a:endParaRPr lang="en-US"/>
           </a:p>
@@ -760,7 +759,7 @@
           <a:p>
             <a:fld id="{13FC26C8-C37B-D543-9AB9-4FE91B5DFE38}" type="slidenum">
               <a:rPr lang="en-US" smtClean="0"/>
-              <a:t>5</a:t>
+              <a:t>4</a:t>
             </a:fld>
             <a:endParaRPr lang="en-US"/>
           </a:p>
@@ -868,7 +867,7 @@
           <a:p>
             <a:fld id="{13FC26C8-C37B-D543-9AB9-4FE91B5DFE38}" type="slidenum">
               <a:rPr lang="en-US" smtClean="0"/>
-              <a:t>6</a:t>
+              <a:t>5</a:t>
             </a:fld>
             <a:endParaRPr lang="en-US"/>
           </a:p>
@@ -976,7 +975,7 @@
           <a:p>
             <a:fld id="{13FC26C8-C37B-D543-9AB9-4FE91B5DFE38}" type="slidenum">
               <a:rPr lang="en-US" smtClean="0"/>
-              <a:t>7</a:t>
+              <a:t>6</a:t>
             </a:fld>
             <a:endParaRPr lang="en-US"/>
           </a:p>
@@ -1084,7 +1083,7 @@
           <a:p>
             <a:fld id="{13FC26C8-C37B-D543-9AB9-4FE91B5DFE38}" type="slidenum">
               <a:rPr lang="en-US" smtClean="0"/>
-              <a:t>8</a:t>
+              <a:t>7</a:t>
             </a:fld>
             <a:endParaRPr lang="en-US"/>
           </a:p>
@@ -1192,7 +1191,7 @@
           <a:p>
             <a:fld id="{13FC26C8-C37B-D543-9AB9-4FE91B5DFE38}" type="slidenum">
               <a:rPr lang="en-US" smtClean="0"/>
-              <a:t>9</a:t>
+              <a:t>8</a:t>
             </a:fld>
             <a:endParaRPr lang="en-US"/>
           </a:p>
@@ -1300,7 +1299,7 @@
           <a:p>
             <a:fld id="{13FC26C8-C37B-D543-9AB9-4FE91B5DFE38}" type="slidenum">
               <a:rPr lang="en-US" smtClean="0"/>
-              <a:t>12</a:t>
+              <a:t>11</a:t>
             </a:fld>
             <a:endParaRPr lang="en-US"/>
           </a:p>
@@ -1408,7 +1407,7 @@
           <a:p>
             <a:fld id="{13FC26C8-C37B-D543-9AB9-4FE91B5DFE38}" type="slidenum">
               <a:rPr lang="en-US" smtClean="0"/>
-              <a:t>13</a:t>
+              <a:t>12</a:t>
             </a:fld>
             <a:endParaRPr lang="en-US"/>
           </a:p>
@@ -1516,7 +1515,7 @@
           <a:p>
             <a:fld id="{13FC26C8-C37B-D543-9AB9-4FE91B5DFE38}" type="slidenum">
               <a:rPr lang="en-US" smtClean="0"/>
-              <a:t>14</a:t>
+              <a:t>13</a:t>
             </a:fld>
             <a:endParaRPr lang="en-US"/>
           </a:p>
@@ -1682,7 +1681,7 @@
           <a:p>
             <a:fld id="{FDED4967-6235-1D43-8395-C7AE9E7B6672}" type="datetimeFigureOut">
               <a:rPr lang="en-US" smtClean="0"/>
-              <a:t>5/12/26</a:t>
+              <a:t>5/13/26</a:t>
             </a:fld>
             <a:endParaRPr lang="en-US"/>
           </a:p>
@@ -1880,7 +1879,7 @@
           <a:p>
             <a:fld id="{FDED4967-6235-1D43-8395-C7AE9E7B6672}" type="datetimeFigureOut">
               <a:rPr lang="en-US" smtClean="0"/>
-              <a:t>5/12/26</a:t>
+              <a:t>5/13/26</a:t>
             </a:fld>
             <a:endParaRPr lang="en-US"/>
           </a:p>
@@ -2088,7 +2087,7 @@
           <a:p>
             <a:fld id="{FDED4967-6235-1D43-8395-C7AE9E7B6672}" type="datetimeFigureOut">
               <a:rPr lang="en-US" smtClean="0"/>
-              <a:t>5/12/26</a:t>
+              <a:t>5/13/26</a:t>
             </a:fld>
             <a:endParaRPr lang="en-US"/>
           </a:p>
@@ -2286,7 +2285,7 @@
           <a:p>
             <a:fld id="{FDED4967-6235-1D43-8395-C7AE9E7B6672}" type="datetimeFigureOut">
               <a:rPr lang="en-US" smtClean="0"/>
-              <a:t>5/12/26</a:t>
+              <a:t>5/13/26</a:t>
             </a:fld>
             <a:endParaRPr lang="en-US"/>
           </a:p>
@@ -2561,7 +2560,7 @@
           <a:p>
             <a:fld id="{FDED4967-6235-1D43-8395-C7AE9E7B6672}" type="datetimeFigureOut">
               <a:rPr lang="en-US" smtClean="0"/>
-              <a:t>5/12/26</a:t>
+              <a:t>5/13/26</a:t>
             </a:fld>
             <a:endParaRPr lang="en-US"/>
           </a:p>
@@ -2826,7 +2825,7 @@
           <a:p>
             <a:fld id="{FDED4967-6235-1D43-8395-C7AE9E7B6672}" type="datetimeFigureOut">
               <a:rPr lang="en-US" smtClean="0"/>
-              <a:t>5/12/26</a:t>
+              <a:t>5/13/26</a:t>
             </a:fld>
             <a:endParaRPr lang="en-US"/>
           </a:p>
@@ -3238,7 +3237,7 @@
           <a:p>
             <a:fld id="{FDED4967-6235-1D43-8395-C7AE9E7B6672}" type="datetimeFigureOut">
               <a:rPr lang="en-US" smtClean="0"/>
-              <a:t>5/12/26</a:t>
+              <a:t>5/13/26</a:t>
             </a:fld>
             <a:endParaRPr lang="en-US"/>
           </a:p>
@@ -3379,7 +3378,7 @@
           <a:p>
             <a:fld id="{FDED4967-6235-1D43-8395-C7AE9E7B6672}" type="datetimeFigureOut">
               <a:rPr lang="en-US" smtClean="0"/>
-              <a:t>5/12/26</a:t>
+              <a:t>5/13/26</a:t>
             </a:fld>
             <a:endParaRPr lang="en-US"/>
           </a:p>
@@ -3492,7 +3491,7 @@
           <a:p>
             <a:fld id="{FDED4967-6235-1D43-8395-C7AE9E7B6672}" type="datetimeFigureOut">
               <a:rPr lang="en-US" smtClean="0"/>
-              <a:t>5/12/26</a:t>
+              <a:t>5/13/26</a:t>
             </a:fld>
             <a:endParaRPr lang="en-US"/>
           </a:p>
@@ -3803,7 +3802,7 @@
           <a:p>
             <a:fld id="{FDED4967-6235-1D43-8395-C7AE9E7B6672}" type="datetimeFigureOut">
               <a:rPr lang="en-US" smtClean="0"/>
-              <a:t>5/12/26</a:t>
+              <a:t>5/13/26</a:t>
             </a:fld>
             <a:endParaRPr lang="en-US"/>
           </a:p>
@@ -4091,7 +4090,7 @@
           <a:p>
             <a:fld id="{FDED4967-6235-1D43-8395-C7AE9E7B6672}" type="datetimeFigureOut">
               <a:rPr lang="en-US" smtClean="0"/>
-              <a:t>5/12/26</a:t>
+              <a:t>5/13/26</a:t>
             </a:fld>
             <a:endParaRPr lang="en-US"/>
           </a:p>
@@ -4332,7 +4331,7 @@
           <a:p>
             <a:fld id="{FDED4967-6235-1D43-8395-C7AE9E7B6672}" type="datetimeFigureOut">
               <a:rPr lang="en-US" smtClean="0"/>
-              <a:t>5/12/26</a:t>
+              <a:t>5/13/26</a:t>
             </a:fld>
             <a:endParaRPr lang="en-US"/>
           </a:p>
@@ -5001,472 +5000,6 @@
   <p:cSld>
     <p:spTree>
       <p:nvGrpSpPr>
-        <p:cNvPr id="1" name=""/>
-        <p:cNvGrpSpPr/>
-        <p:nvPr/>
-      </p:nvGrpSpPr>
-      <p:grpSpPr>
-        <a:xfrm>
-          <a:off x="0" y="0"/>
-          <a:ext cx="0" cy="0"/>
-          <a:chOff x="0" y="0"/>
-          <a:chExt cx="0" cy="0"/>
-        </a:xfrm>
-      </p:grpSpPr>
-      <p:pic>
-        <p:nvPicPr>
-          <p:cNvPr id="4" name="Picture 3">
-            <a:extLst>
-              <a:ext uri="{FF2B5EF4-FFF2-40B4-BE49-F238E27FC236}">
-                <a16:creationId xmlns:a16="http://schemas.microsoft.com/office/drawing/2014/main" id="{98A9F10A-D308-A630-8879-180A7D4E34B7}"/>
-              </a:ext>
-            </a:extLst>
-          </p:cNvPr>
-          <p:cNvPicPr>
-            <a:picLocks noChangeAspect="1"/>
-          </p:cNvPicPr>
-          <p:nvPr/>
-        </p:nvPicPr>
-        <p:blipFill>
-          <a:blip r:embed="rId2"/>
-          <a:stretch>
-            <a:fillRect/>
-          </a:stretch>
-        </p:blipFill>
-        <p:spPr>
-          <a:xfrm>
-            <a:off x="5080000" y="4268283"/>
-            <a:ext cx="6827520" cy="2432607"/>
-          </a:xfrm>
-          <a:prstGeom prst="rect">
-            <a:avLst/>
-          </a:prstGeom>
-        </p:spPr>
-      </p:pic>
-      <p:sp>
-        <p:nvSpPr>
-          <p:cNvPr id="6" name="TextBox 5">
-            <a:extLst>
-              <a:ext uri="{FF2B5EF4-FFF2-40B4-BE49-F238E27FC236}">
-                <a16:creationId xmlns:a16="http://schemas.microsoft.com/office/drawing/2014/main" id="{07DE6C1D-7466-C266-83F3-7C483D86F8C4}"/>
-              </a:ext>
-            </a:extLst>
-          </p:cNvPr>
-          <p:cNvSpPr txBox="1"/>
-          <p:nvPr/>
-        </p:nvSpPr>
-        <p:spPr>
-          <a:xfrm>
-            <a:off x="1097280" y="2019969"/>
-            <a:ext cx="6096000" cy="2031325"/>
-          </a:xfrm>
-          <a:prstGeom prst="rect">
-            <a:avLst/>
-          </a:prstGeom>
-          <a:solidFill>
-            <a:schemeClr val="bg1">
-              <a:lumMod val="95000"/>
-            </a:schemeClr>
-          </a:solidFill>
-        </p:spPr>
-        <p:txBody>
-          <a:bodyPr wrap="square">
-            <a:spAutoFit/>
-          </a:bodyPr>
-          <a:lstStyle/>
-          <a:p>
-            <a:r>
-              <a:rPr lang="en-US" b="0" i="0" dirty="0">
-                <a:solidFill>
-                  <a:srgbClr val="5E5E5E"/>
-                </a:solidFill>
-                <a:effectLst/>
-                <a:latin typeface="SFMono-Regular"/>
-              </a:rPr>
-              <a:t># Submit a test job</a:t>
-            </a:r>
-            <a:r>
-              <a:rPr lang="en-US" b="0" i="0" dirty="0">
-                <a:solidFill>
-                  <a:srgbClr val="003B4F"/>
-                </a:solidFill>
-                <a:effectLst/>
-                <a:latin typeface="SFMono-Regular"/>
-              </a:rPr>
-              <a:t> </a:t>
-            </a:r>
-          </a:p>
-          <a:p>
-            <a:r>
-              <a:rPr lang="en-US" b="0" i="0" dirty="0" err="1">
-                <a:solidFill>
-                  <a:srgbClr val="003B4F"/>
-                </a:solidFill>
-                <a:effectLst/>
-                <a:latin typeface="SFMono-Regular"/>
-              </a:rPr>
-              <a:t>bsub</a:t>
-            </a:r>
-            <a:r>
-              <a:rPr lang="en-US" b="0" i="0" dirty="0">
-                <a:solidFill>
-                  <a:srgbClr val="003B4F"/>
-                </a:solidFill>
-                <a:effectLst/>
-                <a:latin typeface="SFMono-Regular"/>
-              </a:rPr>
-              <a:t> &lt; </a:t>
-            </a:r>
-            <a:r>
-              <a:rPr lang="en-US" b="0" i="0" dirty="0" err="1">
-                <a:solidFill>
-                  <a:srgbClr val="003B4F"/>
-                </a:solidFill>
-                <a:effectLst/>
-                <a:latin typeface="SFMono-Regular"/>
-              </a:rPr>
-              <a:t>test_program.lsf</a:t>
-            </a:r>
-            <a:r>
-              <a:rPr lang="en-US" b="0" i="0" dirty="0">
-                <a:solidFill>
-                  <a:srgbClr val="003B4F"/>
-                </a:solidFill>
-                <a:effectLst/>
-                <a:latin typeface="SFMono-Regular"/>
-              </a:rPr>
-              <a:t> </a:t>
-            </a:r>
-          </a:p>
-          <a:p>
-            <a:r>
-              <a:rPr lang="en-US" b="0" i="0" dirty="0">
-                <a:solidFill>
-                  <a:srgbClr val="5E5E5E"/>
-                </a:solidFill>
-                <a:effectLst/>
-                <a:latin typeface="SFMono-Regular"/>
-              </a:rPr>
-              <a:t># Get job ID and monitor</a:t>
-            </a:r>
-            <a:r>
-              <a:rPr lang="en-US" b="0" i="0" dirty="0">
-                <a:solidFill>
-                  <a:srgbClr val="003B4F"/>
-                </a:solidFill>
-                <a:effectLst/>
-                <a:latin typeface="SFMono-Regular"/>
-              </a:rPr>
-              <a:t> </a:t>
-            </a:r>
-          </a:p>
-          <a:p>
-            <a:r>
-              <a:rPr lang="en-US" b="0" i="0" dirty="0" err="1">
-                <a:solidFill>
-                  <a:srgbClr val="003B4F"/>
-                </a:solidFill>
-                <a:effectLst/>
-                <a:latin typeface="SFMono-Regular"/>
-              </a:rPr>
-              <a:t>bjobs</a:t>
-            </a:r>
-            <a:r>
-              <a:rPr lang="en-US" b="0" i="0" dirty="0">
-                <a:solidFill>
-                  <a:srgbClr val="003B4F"/>
-                </a:solidFill>
-                <a:effectLst/>
-                <a:latin typeface="SFMono-Regular"/>
-              </a:rPr>
-              <a:t> </a:t>
-            </a:r>
-          </a:p>
-          <a:p>
-            <a:r>
-              <a:rPr lang="en-US" b="0" i="0" dirty="0">
-                <a:solidFill>
-                  <a:srgbClr val="5E5E5E"/>
-                </a:solidFill>
-                <a:effectLst/>
-                <a:latin typeface="SFMono-Regular"/>
-              </a:rPr>
-              <a:t># After completion, check performance</a:t>
-            </a:r>
-            <a:r>
-              <a:rPr lang="en-US" b="0" i="0" dirty="0">
-                <a:solidFill>
-                  <a:srgbClr val="003B4F"/>
-                </a:solidFill>
-                <a:effectLst/>
-                <a:latin typeface="SFMono-Regular"/>
-              </a:rPr>
-              <a:t> </a:t>
-            </a:r>
-          </a:p>
-          <a:p>
-            <a:r>
-              <a:rPr lang="en-US" b="0" i="0" dirty="0" err="1">
-                <a:solidFill>
-                  <a:srgbClr val="003B4F"/>
-                </a:solidFill>
-                <a:effectLst/>
-                <a:latin typeface="SFMono-Regular"/>
-              </a:rPr>
-              <a:t>bjobs</a:t>
-            </a:r>
-            <a:r>
-              <a:rPr lang="en-US" b="0" i="0" dirty="0">
-                <a:solidFill>
-                  <a:srgbClr val="003B4F"/>
-                </a:solidFill>
-                <a:effectLst/>
-                <a:latin typeface="SFMono-Regular"/>
-              </a:rPr>
-              <a:t> </a:t>
-            </a:r>
-            <a:r>
-              <a:rPr lang="en-US" b="0" i="0" dirty="0">
-                <a:solidFill>
-                  <a:srgbClr val="657422"/>
-                </a:solidFill>
-                <a:effectLst/>
-                <a:latin typeface="SFMono-Regular"/>
-              </a:rPr>
-              <a:t>-l</a:t>
-            </a:r>
-            <a:r>
-              <a:rPr lang="en-US" b="0" i="0" dirty="0">
-                <a:solidFill>
-                  <a:srgbClr val="003B4F"/>
-                </a:solidFill>
-                <a:effectLst/>
-                <a:latin typeface="SFMono-Regular"/>
-              </a:rPr>
-              <a:t> JOBID </a:t>
-            </a:r>
-            <a:r>
-              <a:rPr lang="en-US" b="0" i="0" dirty="0">
-                <a:solidFill>
-                  <a:srgbClr val="5E5E5E"/>
-                </a:solidFill>
-                <a:effectLst/>
-                <a:latin typeface="SFMono-Regular"/>
-              </a:rPr>
-              <a:t>&gt;</a:t>
-            </a:r>
-            <a:r>
-              <a:rPr lang="en-US" b="0" i="0" dirty="0">
-                <a:solidFill>
-                  <a:srgbClr val="003B4F"/>
-                </a:solidFill>
-                <a:effectLst/>
-                <a:latin typeface="SFMono-Regular"/>
-              </a:rPr>
-              <a:t> </a:t>
-            </a:r>
-            <a:r>
-              <a:rPr lang="en-US" b="0" i="0" dirty="0" err="1">
-                <a:solidFill>
-                  <a:srgbClr val="003B4F"/>
-                </a:solidFill>
-                <a:effectLst/>
-                <a:latin typeface="SFMono-Regular"/>
-              </a:rPr>
-              <a:t>job_analysis.txt</a:t>
-            </a:r>
-            <a:r>
-              <a:rPr lang="en-US" b="0" i="0" dirty="0">
-                <a:solidFill>
-                  <a:srgbClr val="003B4F"/>
-                </a:solidFill>
-                <a:effectLst/>
-                <a:latin typeface="SFMono-Regular"/>
-              </a:rPr>
-              <a:t> </a:t>
-            </a:r>
-          </a:p>
-          <a:p>
-            <a:r>
-              <a:rPr lang="en-US" b="0" i="0" dirty="0">
-                <a:solidFill>
-                  <a:srgbClr val="5E5E5E"/>
-                </a:solidFill>
-                <a:effectLst/>
-                <a:latin typeface="SFMono-Regular"/>
-              </a:rPr>
-              <a:t># Look at the output</a:t>
-            </a:r>
-            <a:r>
-              <a:rPr lang="en-US" b="0" i="0" dirty="0">
-                <a:solidFill>
-                  <a:srgbClr val="003B4F"/>
-                </a:solidFill>
-                <a:effectLst/>
-                <a:latin typeface="SFMono-Regular"/>
-              </a:rPr>
-              <a:t> </a:t>
-            </a:r>
-            <a:r>
-              <a:rPr lang="en-US" b="0" i="0" dirty="0">
-                <a:solidFill>
-                  <a:srgbClr val="4758AB"/>
-                </a:solidFill>
-                <a:effectLst/>
-                <a:latin typeface="SFMono-Regular"/>
-              </a:rPr>
-              <a:t>less</a:t>
-            </a:r>
-            <a:r>
-              <a:rPr lang="en-US" b="0" i="0" dirty="0">
-                <a:solidFill>
-                  <a:srgbClr val="003B4F"/>
-                </a:solidFill>
-                <a:effectLst/>
-                <a:latin typeface="SFMono-Regular"/>
-              </a:rPr>
-              <a:t> </a:t>
-            </a:r>
-            <a:r>
-              <a:rPr lang="en-US" b="0" i="0" dirty="0" err="1">
-                <a:solidFill>
-                  <a:srgbClr val="003B4F"/>
-                </a:solidFill>
-                <a:effectLst/>
-                <a:latin typeface="SFMono-Regular"/>
-              </a:rPr>
-              <a:t>job_analysis.txt</a:t>
-            </a:r>
-            <a:endParaRPr lang="en-US" dirty="0"/>
-          </a:p>
-        </p:txBody>
-      </p:sp>
-      <p:sp>
-        <p:nvSpPr>
-          <p:cNvPr id="7" name="Title 1">
-            <a:extLst>
-              <a:ext uri="{FF2B5EF4-FFF2-40B4-BE49-F238E27FC236}">
-                <a16:creationId xmlns:a16="http://schemas.microsoft.com/office/drawing/2014/main" id="{A6235CDC-EE1E-94B5-0325-9BBB7D9272B7}"/>
-              </a:ext>
-            </a:extLst>
-          </p:cNvPr>
-          <p:cNvSpPr txBox="1">
-            <a:spLocks/>
-          </p:cNvSpPr>
-          <p:nvPr/>
-        </p:nvSpPr>
-        <p:spPr>
-          <a:xfrm>
-            <a:off x="990600" y="517525"/>
-            <a:ext cx="10515600" cy="1325563"/>
-          </a:xfrm>
-          <a:prstGeom prst="rect">
-            <a:avLst/>
-          </a:prstGeom>
-        </p:spPr>
-        <p:txBody>
-          <a:bodyPr vert="horz" lIns="91440" tIns="45720" rIns="91440" bIns="45720" rtlCol="0" anchor="ctr">
-            <a:normAutofit/>
-          </a:bodyPr>
-          <a:lstStyle>
-            <a:lvl1pPr algn="l" defTabSz="914400" rtl="0" eaLnBrk="1" latinLnBrk="0" hangingPunct="1">
-              <a:lnSpc>
-                <a:spcPct val="90000"/>
-              </a:lnSpc>
-              <a:spcBef>
-                <a:spcPct val="0"/>
-              </a:spcBef>
-              <a:buNone/>
-              <a:defRPr sz="4400" kern="1200">
-                <a:solidFill>
-                  <a:schemeClr val="tx1"/>
-                </a:solidFill>
-                <a:latin typeface="+mj-lt"/>
-                <a:ea typeface="+mj-ea"/>
-                <a:cs typeface="+mj-cs"/>
-              </a:defRPr>
-            </a:lvl1pPr>
-          </a:lstStyle>
-          <a:p>
-            <a:r>
-              <a:rPr lang="en-US" b="1" dirty="0"/>
-              <a:t>Analyzing a Job</a:t>
-            </a:r>
-          </a:p>
-        </p:txBody>
-      </p:sp>
-      <p:pic>
-        <p:nvPicPr>
-          <p:cNvPr id="8" name="Picture 6" descr="coding Symbol mark in filled style 47628836 Vector Art at Vecteezy">
-            <a:extLst>
-              <a:ext uri="{FF2B5EF4-FFF2-40B4-BE49-F238E27FC236}">
-                <a16:creationId xmlns:a16="http://schemas.microsoft.com/office/drawing/2014/main" id="{2BF86E23-7D18-32E7-C0EE-D15E80F66D1C}"/>
-              </a:ext>
-            </a:extLst>
-          </p:cNvPr>
-          <p:cNvPicPr>
-            <a:picLocks noChangeAspect="1" noChangeArrowheads="1"/>
-          </p:cNvPicPr>
-          <p:nvPr/>
-        </p:nvPicPr>
-        <p:blipFill>
-          <a:blip r:embed="rId3">
-            <a:duotone>
-              <a:prstClr val="black"/>
-              <a:schemeClr val="accent4">
-                <a:tint val="45000"/>
-                <a:satMod val="400000"/>
-              </a:schemeClr>
-            </a:duotone>
-            <a:extLst>
-              <a:ext uri="{28A0092B-C50C-407E-A947-70E740481C1C}">
-                <a14:useLocalDpi xmlns:a14="http://schemas.microsoft.com/office/drawing/2010/main" val="0"/>
-              </a:ext>
-            </a:extLst>
-          </a:blip>
-          <a:srcRect/>
-          <a:stretch>
-            <a:fillRect/>
-          </a:stretch>
-        </p:blipFill>
-        <p:spPr bwMode="auto">
-          <a:xfrm>
-            <a:off x="4917440" y="626429"/>
-            <a:ext cx="904240" cy="904240"/>
-          </a:xfrm>
-          <a:prstGeom prst="rect">
-            <a:avLst/>
-          </a:prstGeom>
-          <a:noFill/>
-          <a:extLst>
-            <a:ext uri="{909E8E84-426E-40DD-AFC4-6F175D3DCCD1}">
-              <a14:hiddenFill xmlns:a14="http://schemas.microsoft.com/office/drawing/2010/main">
-                <a:solidFill>
-                  <a:srgbClr val="FFFFFF"/>
-                </a:solidFill>
-              </a14:hiddenFill>
-            </a:ext>
-          </a:extLst>
-        </p:spPr>
-      </p:pic>
-    </p:spTree>
-    <p:extLst>
-      <p:ext uri="{BB962C8B-B14F-4D97-AF65-F5344CB8AC3E}">
-        <p14:creationId xmlns:p14="http://schemas.microsoft.com/office/powerpoint/2010/main" val="1529687703"/>
-      </p:ext>
-    </p:extLst>
-  </p:cSld>
-  <p:clrMapOvr>
-    <a:masterClrMapping/>
-  </p:clrMapOvr>
-</p:sld>
-</file>
-
-<file path=ppt/slides/slide11.xml><?xml version="1.0" encoding="utf-8"?>
-<p:sld xmlns:a="http://schemas.openxmlformats.org/drawingml/2006/main" xmlns:r="http://schemas.openxmlformats.org/officeDocument/2006/relationships" xmlns:p="http://schemas.openxmlformats.org/presentationml/2006/main">
-  <p:cSld>
-    <p:spTree>
-      <p:nvGrpSpPr>
         <p:cNvPr id="1" name="">
           <a:extLst>
             <a:ext uri="{FF2B5EF4-FFF2-40B4-BE49-F238E27FC236}">
@@ -5601,7 +5134,7 @@
 </p:sld>
 </file>
 
-<file path=ppt/slides/slide12.xml><?xml version="1.0" encoding="utf-8"?>
+<file path=ppt/slides/slide11.xml><?xml version="1.0" encoding="utf-8"?>
 <p:sld xmlns:a="http://schemas.openxmlformats.org/drawingml/2006/main" xmlns:r="http://schemas.openxmlformats.org/officeDocument/2006/relationships" xmlns:p="http://schemas.openxmlformats.org/presentationml/2006/main">
   <p:cSld>
     <p:spTree>
@@ -5886,7 +5419,7 @@
 </p:sld>
 </file>
 
-<file path=ppt/slides/slide13.xml><?xml version="1.0" encoding="utf-8"?>
+<file path=ppt/slides/slide12.xml><?xml version="1.0" encoding="utf-8"?>
 <p:sld xmlns:a="http://schemas.openxmlformats.org/drawingml/2006/main" xmlns:r="http://schemas.openxmlformats.org/officeDocument/2006/relationships" xmlns:p="http://schemas.openxmlformats.org/presentationml/2006/main">
   <p:cSld>
     <p:spTree>
@@ -6694,7 +6227,7 @@
 </p:sld>
 </file>
 
-<file path=ppt/slides/slide14.xml><?xml version="1.0" encoding="utf-8"?>
+<file path=ppt/slides/slide13.xml><?xml version="1.0" encoding="utf-8"?>
 <p:sld xmlns:a="http://schemas.openxmlformats.org/drawingml/2006/main" xmlns:r="http://schemas.openxmlformats.org/officeDocument/2006/relationships" xmlns:p="http://schemas.openxmlformats.org/presentationml/2006/main">
   <p:cSld>
     <p:spTree>
@@ -7589,7 +7122,7 @@
 </p:sld>
 </file>
 
-<file path=ppt/slides/slide15.xml><?xml version="1.0" encoding="utf-8"?>
+<file path=ppt/slides/slide14.xml><?xml version="1.0" encoding="utf-8"?>
 <p:sld xmlns:a="http://schemas.openxmlformats.org/drawingml/2006/main" xmlns:r="http://schemas.openxmlformats.org/officeDocument/2006/relationships" xmlns:p="http://schemas.openxmlformats.org/presentationml/2006/main">
   <p:cSld>
     <p:spTree>
@@ -8670,7 +8203,7 @@
 </p:sld>
 </file>
 
-<file path=ppt/slides/slide16.xml><?xml version="1.0" encoding="utf-8"?>
+<file path=ppt/slides/slide15.xml><?xml version="1.0" encoding="utf-8"?>
 <p:sld xmlns:a="http://schemas.openxmlformats.org/drawingml/2006/main" xmlns:r="http://schemas.openxmlformats.org/officeDocument/2006/relationships" xmlns:p="http://schemas.openxmlformats.org/presentationml/2006/main">
   <p:cSld>
     <p:spTree>
@@ -8801,36 +8334,6 @@
           </a:extLst>
         </p:spPr>
       </p:pic>
-      <p:pic>
-        <p:nvPicPr>
-          <p:cNvPr id="5" name="Picture 4">
-            <a:extLst>
-              <a:ext uri="{FF2B5EF4-FFF2-40B4-BE49-F238E27FC236}">
-                <a16:creationId xmlns:a16="http://schemas.microsoft.com/office/drawing/2014/main" id="{29CCC1F4-6203-C286-A20E-2845F594F4DE}"/>
-              </a:ext>
-            </a:extLst>
-          </p:cNvPr>
-          <p:cNvPicPr>
-            <a:picLocks noChangeAspect="1"/>
-          </p:cNvPicPr>
-          <p:nvPr/>
-        </p:nvPicPr>
-        <p:blipFill>
-          <a:blip r:embed="rId3"/>
-          <a:stretch>
-            <a:fillRect/>
-          </a:stretch>
-        </p:blipFill>
-        <p:spPr>
-          <a:xfrm>
-            <a:off x="1149530" y="2258423"/>
-            <a:ext cx="5606143" cy="4411585"/>
-          </a:xfrm>
-          <a:prstGeom prst="rect">
-            <a:avLst/>
-          </a:prstGeom>
-        </p:spPr>
-      </p:pic>
       <p:sp>
         <p:nvSpPr>
           <p:cNvPr id="9" name="TextBox 8">
@@ -8866,55 +8369,36 @@
           </a:p>
         </p:txBody>
       </p:sp>
-      <p:sp>
-        <p:nvSpPr>
-          <p:cNvPr id="2" name="5-Point Star 1">
-            <a:extLst>
-              <a:ext uri="{FF2B5EF4-FFF2-40B4-BE49-F238E27FC236}">
-                <a16:creationId xmlns:a16="http://schemas.microsoft.com/office/drawing/2014/main" id="{9EDE85D6-96A6-E25A-D1E0-10003BE96645}"/>
-              </a:ext>
-            </a:extLst>
-          </p:cNvPr>
-          <p:cNvSpPr/>
+      <p:pic>
+        <p:nvPicPr>
+          <p:cNvPr id="3" name="Picture 2">
+            <a:extLst>
+              <a:ext uri="{FF2B5EF4-FFF2-40B4-BE49-F238E27FC236}">
+                <a16:creationId xmlns:a16="http://schemas.microsoft.com/office/drawing/2014/main" id="{5ADC708E-7083-7769-A6B8-3F60A6087517}"/>
+              </a:ext>
+            </a:extLst>
+          </p:cNvPr>
+          <p:cNvPicPr>
+            <a:picLocks noChangeAspect="1"/>
+          </p:cNvPicPr>
           <p:nvPr/>
-        </p:nvSpPr>
+        </p:nvPicPr>
+        <p:blipFill>
+          <a:blip r:embed="rId3"/>
+          <a:stretch>
+            <a:fillRect/>
+          </a:stretch>
+        </p:blipFill>
         <p:spPr>
           <a:xfrm>
-            <a:off x="2102069" y="126124"/>
-            <a:ext cx="8019393" cy="6117021"/>
+            <a:off x="1389415" y="2212420"/>
+            <a:ext cx="4590629" cy="4532764"/>
           </a:xfrm>
-          <a:prstGeom prst="star5">
+          <a:prstGeom prst="rect">
             <a:avLst/>
           </a:prstGeom>
-          <a:solidFill>
-            <a:srgbClr val="7030A0"/>
-          </a:solidFill>
         </p:spPr>
-        <p:style>
-          <a:lnRef idx="2">
-            <a:schemeClr val="accent1">
-              <a:shade val="15000"/>
-            </a:schemeClr>
-          </a:lnRef>
-          <a:fillRef idx="1">
-            <a:schemeClr val="accent1"/>
-          </a:fillRef>
-          <a:effectRef idx="0">
-            <a:schemeClr val="accent1"/>
-          </a:effectRef>
-          <a:fontRef idx="minor">
-            <a:schemeClr val="lt1"/>
-          </a:fontRef>
-        </p:style>
-        <p:txBody>
-          <a:bodyPr rtlCol="0" anchor="ctr"/>
-          <a:lstStyle/>
-          <a:p>
-            <a:pPr algn="ctr"/>
-            <a:endParaRPr lang="en-US"/>
-          </a:p>
-        </p:txBody>
-      </p:sp>
+      </p:pic>
     </p:spTree>
     <p:extLst>
       <p:ext uri="{BB962C8B-B14F-4D97-AF65-F5344CB8AC3E}">
@@ -10854,243 +10338,6 @@
         <p:cNvPr id="1" name="">
           <a:extLst>
             <a:ext uri="{FF2B5EF4-FFF2-40B4-BE49-F238E27FC236}">
-              <a16:creationId xmlns:a16="http://schemas.microsoft.com/office/drawing/2014/main" id="{45849598-BD4D-70E9-70C2-7215FDC0508E}"/>
-            </a:ext>
-          </a:extLst>
-        </p:cNvPr>
-        <p:cNvGrpSpPr/>
-        <p:nvPr/>
-      </p:nvGrpSpPr>
-      <p:grpSpPr>
-        <a:xfrm>
-          <a:off x="0" y="0"/>
-          <a:ext cx="0" cy="0"/>
-          <a:chOff x="0" y="0"/>
-          <a:chExt cx="0" cy="0"/>
-        </a:xfrm>
-      </p:grpSpPr>
-      <p:sp>
-        <p:nvSpPr>
-          <p:cNvPr id="2" name="Title 1">
-            <a:extLst>
-              <a:ext uri="{FF2B5EF4-FFF2-40B4-BE49-F238E27FC236}">
-                <a16:creationId xmlns:a16="http://schemas.microsoft.com/office/drawing/2014/main" id="{FFF1D083-096E-849D-8015-B191ED5D6A34}"/>
-              </a:ext>
-            </a:extLst>
-          </p:cNvPr>
-          <p:cNvSpPr>
-            <a:spLocks noGrp="1"/>
-          </p:cNvSpPr>
-          <p:nvPr>
-            <p:ph type="title"/>
-          </p:nvPr>
-        </p:nvSpPr>
-        <p:spPr/>
-        <p:txBody>
-          <a:bodyPr>
-            <a:normAutofit/>
-          </a:bodyPr>
-          <a:lstStyle/>
-          <a:p>
-            <a:r>
-              <a:rPr lang="en-US" sz="4000" dirty="0">
-                <a:latin typeface="Helvetica" pitchFamily="2" charset="0"/>
-              </a:rPr>
-              <a:t>Leave us your feedback!</a:t>
-            </a:r>
-          </a:p>
-        </p:txBody>
-      </p:sp>
-      <p:pic>
-        <p:nvPicPr>
-          <p:cNvPr id="2050" name="Picture 2" descr="Suggestion - Free communications icons">
-            <a:extLst>
-              <a:ext uri="{FF2B5EF4-FFF2-40B4-BE49-F238E27FC236}">
-                <a16:creationId xmlns:a16="http://schemas.microsoft.com/office/drawing/2014/main" id="{5020596A-D3B5-18D2-1D37-3B88E5CD788C}"/>
-              </a:ext>
-            </a:extLst>
-          </p:cNvPr>
-          <p:cNvPicPr>
-            <a:picLocks noChangeAspect="1" noChangeArrowheads="1"/>
-          </p:cNvPicPr>
-          <p:nvPr/>
-        </p:nvPicPr>
-        <p:blipFill>
-          <a:blip r:embed="rId2">
-            <a:extLst>
-              <a:ext uri="{28A0092B-C50C-407E-A947-70E740481C1C}">
-                <a14:useLocalDpi xmlns:a14="http://schemas.microsoft.com/office/drawing/2010/main" val="0"/>
-              </a:ext>
-            </a:extLst>
-          </a:blip>
-          <a:srcRect/>
-          <a:stretch>
-            <a:fillRect/>
-          </a:stretch>
-        </p:blipFill>
-        <p:spPr bwMode="auto">
-          <a:xfrm>
-            <a:off x="1182760" y="1866375"/>
-            <a:ext cx="611909" cy="611909"/>
-          </a:xfrm>
-          <a:prstGeom prst="rect">
-            <a:avLst/>
-          </a:prstGeom>
-          <a:noFill/>
-          <a:extLst>
-            <a:ext uri="{909E8E84-426E-40DD-AFC4-6F175D3DCCD1}">
-              <a14:hiddenFill xmlns:a14="http://schemas.microsoft.com/office/drawing/2010/main">
-                <a:solidFill>
-                  <a:srgbClr val="FFFFFF"/>
-                </a:solidFill>
-              </a14:hiddenFill>
-            </a:ext>
-          </a:extLst>
-        </p:spPr>
-      </p:pic>
-      <p:sp>
-        <p:nvSpPr>
-          <p:cNvPr id="3" name="TextBox 2">
-            <a:extLst>
-              <a:ext uri="{FF2B5EF4-FFF2-40B4-BE49-F238E27FC236}">
-                <a16:creationId xmlns:a16="http://schemas.microsoft.com/office/drawing/2014/main" id="{49C98279-5765-9BFA-2B15-04A8FEDAA130}"/>
-              </a:ext>
-            </a:extLst>
-          </p:cNvPr>
-          <p:cNvSpPr txBox="1"/>
-          <p:nvPr/>
-        </p:nvSpPr>
-        <p:spPr>
-          <a:xfrm>
-            <a:off x="1794669" y="2206232"/>
-            <a:ext cx="6591506" cy="1754326"/>
-          </a:xfrm>
-          <a:prstGeom prst="rect">
-            <a:avLst/>
-          </a:prstGeom>
-          <a:noFill/>
-        </p:spPr>
-        <p:txBody>
-          <a:bodyPr wrap="square" rtlCol="0">
-            <a:spAutoFit/>
-          </a:bodyPr>
-          <a:lstStyle/>
-          <a:p>
-            <a:r>
-              <a:rPr lang="en-US" dirty="0">
-                <a:latin typeface="Helvetica" pitchFamily="2" charset="0"/>
-              </a:rPr>
-              <a:t>Please let us know if you have suggestions!</a:t>
-            </a:r>
-          </a:p>
-          <a:p>
-            <a:endParaRPr lang="en-US" dirty="0">
-              <a:latin typeface="Helvetica" pitchFamily="2" charset="0"/>
-            </a:endParaRPr>
-          </a:p>
-          <a:p>
-            <a:pPr marL="342900" indent="-342900">
-              <a:buAutoNum type="arabicPeriod"/>
-            </a:pPr>
-            <a:r>
-              <a:rPr lang="en-US" dirty="0">
-                <a:latin typeface="Helvetica" pitchFamily="2" charset="0"/>
-              </a:rPr>
-              <a:t>What did you like about this workshop?</a:t>
-            </a:r>
-          </a:p>
-          <a:p>
-            <a:pPr marL="342900" indent="-342900">
-              <a:buAutoNum type="arabicPeriod"/>
-            </a:pPr>
-            <a:r>
-              <a:rPr lang="en-US" dirty="0">
-                <a:latin typeface="Helvetica" pitchFamily="2" charset="0"/>
-              </a:rPr>
-              <a:t>What could be improved?</a:t>
-            </a:r>
-          </a:p>
-          <a:p>
-            <a:pPr marL="342900" indent="-342900">
-              <a:buAutoNum type="arabicPeriod"/>
-            </a:pPr>
-            <a:r>
-              <a:rPr lang="en-US" dirty="0">
-                <a:latin typeface="Helvetica" pitchFamily="2" charset="0"/>
-              </a:rPr>
-              <a:t>Any suggestions for the following sessions (i.e. change in order, other topics, special interests)</a:t>
-            </a:r>
-          </a:p>
-        </p:txBody>
-      </p:sp>
-      <p:pic>
-        <p:nvPicPr>
-          <p:cNvPr id="5122" name="Picture 2" descr="Pen Icon Graphic by rudezstudio · Creative Fabrica">
-            <a:extLst>
-              <a:ext uri="{FF2B5EF4-FFF2-40B4-BE49-F238E27FC236}">
-                <a16:creationId xmlns:a16="http://schemas.microsoft.com/office/drawing/2014/main" id="{0DEEB3E2-D200-94F1-EB2C-1F94DD52C3EE}"/>
-              </a:ext>
-            </a:extLst>
-          </p:cNvPr>
-          <p:cNvPicPr>
-            <a:picLocks noChangeAspect="1" noChangeArrowheads="1"/>
-          </p:cNvPicPr>
-          <p:nvPr/>
-        </p:nvPicPr>
-        <p:blipFill>
-          <a:blip r:embed="rId3">
-            <a:extLst>
-              <a:ext uri="{28A0092B-C50C-407E-A947-70E740481C1C}">
-                <a14:useLocalDpi xmlns:a14="http://schemas.microsoft.com/office/drawing/2010/main" val="0"/>
-              </a:ext>
-            </a:extLst>
-          </a:blip>
-          <a:srcRect/>
-          <a:stretch>
-            <a:fillRect/>
-          </a:stretch>
-        </p:blipFill>
-        <p:spPr bwMode="auto">
-          <a:xfrm>
-            <a:off x="6521365" y="340845"/>
-            <a:ext cx="1576712" cy="1049329"/>
-          </a:xfrm>
-          <a:prstGeom prst="rect">
-            <a:avLst/>
-          </a:prstGeom>
-          <a:noFill/>
-          <a:extLst>
-            <a:ext uri="{909E8E84-426E-40DD-AFC4-6F175D3DCCD1}">
-              <a14:hiddenFill xmlns:a14="http://schemas.microsoft.com/office/drawing/2010/main">
-                <a:solidFill>
-                  <a:srgbClr val="FFFFFF"/>
-                </a:solidFill>
-              </a14:hiddenFill>
-            </a:ext>
-          </a:extLst>
-        </p:spPr>
-      </p:pic>
-    </p:spTree>
-    <p:extLst>
-      <p:ext uri="{BB962C8B-B14F-4D97-AF65-F5344CB8AC3E}">
-        <p14:creationId xmlns:p14="http://schemas.microsoft.com/office/powerpoint/2010/main" val="2528438318"/>
-      </p:ext>
-    </p:extLst>
-  </p:cSld>
-  <p:clrMapOvr>
-    <a:masterClrMapping/>
-  </p:clrMapOvr>
-</p:sld>
-</file>
-
-<file path=ppt/slides/slide4.xml><?xml version="1.0" encoding="utf-8"?>
-<p:sld xmlns:a="http://schemas.openxmlformats.org/drawingml/2006/main" xmlns:r="http://schemas.openxmlformats.org/officeDocument/2006/relationships" xmlns:p="http://schemas.openxmlformats.org/presentationml/2006/main">
-  <p:cSld>
-    <p:spTree>
-      <p:nvGrpSpPr>
-        <p:cNvPr id="1" name="">
-          <a:extLst>
-            <a:ext uri="{FF2B5EF4-FFF2-40B4-BE49-F238E27FC236}">
               <a16:creationId xmlns:a16="http://schemas.microsoft.com/office/drawing/2014/main" id="{30A7E632-1B08-6D8A-3A25-87625934D76E}"/>
             </a:ext>
           </a:extLst>
@@ -11222,7 +10469,7 @@
 </p:sld>
 </file>
 
-<file path=ppt/slides/slide5.xml><?xml version="1.0" encoding="utf-8"?>
+<file path=ppt/slides/slide4.xml><?xml version="1.0" encoding="utf-8"?>
 <p:sld xmlns:a="http://schemas.openxmlformats.org/drawingml/2006/main" xmlns:r="http://schemas.openxmlformats.org/officeDocument/2006/relationships" xmlns:p="http://schemas.openxmlformats.org/presentationml/2006/main">
   <p:cSld>
     <p:spTree>
@@ -11638,7 +10885,7 @@
 </p:sld>
 </file>
 
-<file path=ppt/slides/slide6.xml><?xml version="1.0" encoding="utf-8"?>
+<file path=ppt/slides/slide5.xml><?xml version="1.0" encoding="utf-8"?>
 <p:sld xmlns:a="http://schemas.openxmlformats.org/drawingml/2006/main" xmlns:r="http://schemas.openxmlformats.org/officeDocument/2006/relationships" xmlns:p="http://schemas.openxmlformats.org/presentationml/2006/main">
   <p:cSld>
     <p:spTree>
@@ -12473,7 +11720,7 @@
 </p:sld>
 </file>
 
-<file path=ppt/slides/slide7.xml><?xml version="1.0" encoding="utf-8"?>
+<file path=ppt/slides/slide6.xml><?xml version="1.0" encoding="utf-8"?>
 <p:sld xmlns:a="http://schemas.openxmlformats.org/drawingml/2006/main" xmlns:r="http://schemas.openxmlformats.org/officeDocument/2006/relationships" xmlns:p="http://schemas.openxmlformats.org/presentationml/2006/main">
   <p:cSld>
     <p:spTree>
@@ -12833,7 +12080,7 @@
 </p:sld>
 </file>
 
-<file path=ppt/slides/slide8.xml><?xml version="1.0" encoding="utf-8"?>
+<file path=ppt/slides/slide7.xml><?xml version="1.0" encoding="utf-8"?>
 <p:sld xmlns:a="http://schemas.openxmlformats.org/drawingml/2006/main" xmlns:r="http://schemas.openxmlformats.org/officeDocument/2006/relationships" xmlns:p="http://schemas.openxmlformats.org/presentationml/2006/main">
   <p:cSld>
     <p:spTree>
@@ -13114,7 +12361,7 @@
         <p:spPr>
           <a:xfrm>
             <a:off x="711200" y="4175760"/>
-            <a:ext cx="10769600" cy="2862322"/>
+            <a:ext cx="10769600" cy="2739211"/>
           </a:xfrm>
           <a:prstGeom prst="rect">
             <a:avLst/>
@@ -13158,37 +12405,37 @@
               <a:buChar char="•"/>
             </a:pPr>
             <a:r>
-              <a:rPr lang="en-US" i="1" dirty="0">
+              <a:rPr lang="en-US" sz="1600" i="1" dirty="0">
                 <a:effectLst/>
               </a:rPr>
               <a:t>Note:</a:t>
             </a:r>
             <a:r>
-              <a:rPr lang="en-US" dirty="0">
+              <a:rPr lang="en-US" sz="1600" dirty="0">
                 <a:effectLst/>
               </a:rPr>
               <a:t> Since your </a:t>
             </a:r>
             <a:r>
-              <a:rPr lang="en-US" b="1" dirty="0">
+              <a:rPr lang="en-US" sz="1600" b="1" dirty="0">
                 <a:effectLst/>
               </a:rPr>
               <a:t>CPU time</a:t>
             </a:r>
             <a:r>
-              <a:rPr lang="en-US" dirty="0">
+              <a:rPr lang="en-US" sz="1600" dirty="0">
                 <a:effectLst/>
               </a:rPr>
               <a:t> (173s) is higher than your </a:t>
             </a:r>
             <a:r>
-              <a:rPr lang="en-US" b="1" dirty="0">
+              <a:rPr lang="en-US" sz="1600" b="1" dirty="0">
                 <a:effectLst/>
               </a:rPr>
               <a:t>Run time</a:t>
             </a:r>
             <a:r>
-              <a:rPr lang="en-US" dirty="0">
+              <a:rPr lang="en-US" sz="1600" dirty="0">
                 <a:effectLst/>
               </a:rPr>
               <a:t> (103s), it confirms your job was multi-threaded or multi-process, utilizing more than one core's worth of processing power.</a:t>
@@ -13218,13 +12465,13 @@
               <a:buChar char="•"/>
             </a:pPr>
             <a:r>
-              <a:rPr lang="en-US" i="1" dirty="0">
+              <a:rPr lang="en-US" sz="1600" i="1" dirty="0">
                 <a:effectLst/>
               </a:rPr>
               <a:t>Note:</a:t>
             </a:r>
             <a:r>
-              <a:rPr lang="en-US" dirty="0">
+              <a:rPr lang="en-US" sz="1600" dirty="0">
                 <a:effectLst/>
               </a:rPr>
               <a:t> In some LSF configurations, if Turnaround is shorter than Run time, it may indicate how LSF tracks the cleanup phase or specific reporting intervals, but generally, these two will be very close.</a:t>
@@ -13248,7 +12495,7 @@
 </p:sld>
 </file>
 
-<file path=ppt/slides/slide9.xml><?xml version="1.0" encoding="utf-8"?>
+<file path=ppt/slides/slide8.xml><?xml version="1.0" encoding="utf-8"?>
 <p:sld xmlns:a="http://schemas.openxmlformats.org/drawingml/2006/main" xmlns:r="http://schemas.openxmlformats.org/officeDocument/2006/relationships" xmlns:p="http://schemas.openxmlformats.org/presentationml/2006/main">
   <p:cSld>
     <p:spTree>
@@ -14283,6 +13530,472 @@
     <p:extLst>
       <p:ext uri="{BB962C8B-B14F-4D97-AF65-F5344CB8AC3E}">
         <p14:creationId xmlns:p14="http://schemas.microsoft.com/office/powerpoint/2010/main" val="615836193"/>
+      </p:ext>
+    </p:extLst>
+  </p:cSld>
+  <p:clrMapOvr>
+    <a:masterClrMapping/>
+  </p:clrMapOvr>
+</p:sld>
+</file>
+
+<file path=ppt/slides/slide9.xml><?xml version="1.0" encoding="utf-8"?>
+<p:sld xmlns:a="http://schemas.openxmlformats.org/drawingml/2006/main" xmlns:r="http://schemas.openxmlformats.org/officeDocument/2006/relationships" xmlns:p="http://schemas.openxmlformats.org/presentationml/2006/main">
+  <p:cSld>
+    <p:spTree>
+      <p:nvGrpSpPr>
+        <p:cNvPr id="1" name=""/>
+        <p:cNvGrpSpPr/>
+        <p:nvPr/>
+      </p:nvGrpSpPr>
+      <p:grpSpPr>
+        <a:xfrm>
+          <a:off x="0" y="0"/>
+          <a:ext cx="0" cy="0"/>
+          <a:chOff x="0" y="0"/>
+          <a:chExt cx="0" cy="0"/>
+        </a:xfrm>
+      </p:grpSpPr>
+      <p:pic>
+        <p:nvPicPr>
+          <p:cNvPr id="4" name="Picture 3">
+            <a:extLst>
+              <a:ext uri="{FF2B5EF4-FFF2-40B4-BE49-F238E27FC236}">
+                <a16:creationId xmlns:a16="http://schemas.microsoft.com/office/drawing/2014/main" id="{98A9F10A-D308-A630-8879-180A7D4E34B7}"/>
+              </a:ext>
+            </a:extLst>
+          </p:cNvPr>
+          <p:cNvPicPr>
+            <a:picLocks noChangeAspect="1"/>
+          </p:cNvPicPr>
+          <p:nvPr/>
+        </p:nvPicPr>
+        <p:blipFill>
+          <a:blip r:embed="rId2"/>
+          <a:stretch>
+            <a:fillRect/>
+          </a:stretch>
+        </p:blipFill>
+        <p:spPr>
+          <a:xfrm>
+            <a:off x="5080000" y="4268283"/>
+            <a:ext cx="6827520" cy="2432607"/>
+          </a:xfrm>
+          <a:prstGeom prst="rect">
+            <a:avLst/>
+          </a:prstGeom>
+        </p:spPr>
+      </p:pic>
+      <p:sp>
+        <p:nvSpPr>
+          <p:cNvPr id="6" name="TextBox 5">
+            <a:extLst>
+              <a:ext uri="{FF2B5EF4-FFF2-40B4-BE49-F238E27FC236}">
+                <a16:creationId xmlns:a16="http://schemas.microsoft.com/office/drawing/2014/main" id="{07DE6C1D-7466-C266-83F3-7C483D86F8C4}"/>
+              </a:ext>
+            </a:extLst>
+          </p:cNvPr>
+          <p:cNvSpPr txBox="1"/>
+          <p:nvPr/>
+        </p:nvSpPr>
+        <p:spPr>
+          <a:xfrm>
+            <a:off x="1097280" y="2019969"/>
+            <a:ext cx="6096000" cy="2031325"/>
+          </a:xfrm>
+          <a:prstGeom prst="rect">
+            <a:avLst/>
+          </a:prstGeom>
+          <a:solidFill>
+            <a:schemeClr val="bg1">
+              <a:lumMod val="95000"/>
+            </a:schemeClr>
+          </a:solidFill>
+        </p:spPr>
+        <p:txBody>
+          <a:bodyPr wrap="square">
+            <a:spAutoFit/>
+          </a:bodyPr>
+          <a:lstStyle/>
+          <a:p>
+            <a:r>
+              <a:rPr lang="en-US" b="0" i="0" dirty="0">
+                <a:solidFill>
+                  <a:srgbClr val="5E5E5E"/>
+                </a:solidFill>
+                <a:effectLst/>
+                <a:latin typeface="SFMono-Regular"/>
+              </a:rPr>
+              <a:t># Submit a test job</a:t>
+            </a:r>
+            <a:r>
+              <a:rPr lang="en-US" b="0" i="0" dirty="0">
+                <a:solidFill>
+                  <a:srgbClr val="003B4F"/>
+                </a:solidFill>
+                <a:effectLst/>
+                <a:latin typeface="SFMono-Regular"/>
+              </a:rPr>
+              <a:t> </a:t>
+            </a:r>
+          </a:p>
+          <a:p>
+            <a:r>
+              <a:rPr lang="en-US" b="0" i="0" dirty="0" err="1">
+                <a:solidFill>
+                  <a:srgbClr val="003B4F"/>
+                </a:solidFill>
+                <a:effectLst/>
+                <a:latin typeface="SFMono-Regular"/>
+              </a:rPr>
+              <a:t>bsub</a:t>
+            </a:r>
+            <a:r>
+              <a:rPr lang="en-US" b="0" i="0" dirty="0">
+                <a:solidFill>
+                  <a:srgbClr val="003B4F"/>
+                </a:solidFill>
+                <a:effectLst/>
+                <a:latin typeface="SFMono-Regular"/>
+              </a:rPr>
+              <a:t> &lt; </a:t>
+            </a:r>
+            <a:r>
+              <a:rPr lang="en-US" b="0" i="0" dirty="0" err="1">
+                <a:solidFill>
+                  <a:srgbClr val="003B4F"/>
+                </a:solidFill>
+                <a:effectLst/>
+                <a:latin typeface="SFMono-Regular"/>
+              </a:rPr>
+              <a:t>test_program.lsf</a:t>
+            </a:r>
+            <a:r>
+              <a:rPr lang="en-US" b="0" i="0" dirty="0">
+                <a:solidFill>
+                  <a:srgbClr val="003B4F"/>
+                </a:solidFill>
+                <a:effectLst/>
+                <a:latin typeface="SFMono-Regular"/>
+              </a:rPr>
+              <a:t> </a:t>
+            </a:r>
+          </a:p>
+          <a:p>
+            <a:r>
+              <a:rPr lang="en-US" b="0" i="0" dirty="0">
+                <a:solidFill>
+                  <a:srgbClr val="5E5E5E"/>
+                </a:solidFill>
+                <a:effectLst/>
+                <a:latin typeface="SFMono-Regular"/>
+              </a:rPr>
+              <a:t># Get job ID and monitor</a:t>
+            </a:r>
+            <a:r>
+              <a:rPr lang="en-US" b="0" i="0" dirty="0">
+                <a:solidFill>
+                  <a:srgbClr val="003B4F"/>
+                </a:solidFill>
+                <a:effectLst/>
+                <a:latin typeface="SFMono-Regular"/>
+              </a:rPr>
+              <a:t> </a:t>
+            </a:r>
+          </a:p>
+          <a:p>
+            <a:r>
+              <a:rPr lang="en-US" b="0" i="0" dirty="0" err="1">
+                <a:solidFill>
+                  <a:srgbClr val="003B4F"/>
+                </a:solidFill>
+                <a:effectLst/>
+                <a:latin typeface="SFMono-Regular"/>
+              </a:rPr>
+              <a:t>bjobs</a:t>
+            </a:r>
+            <a:r>
+              <a:rPr lang="en-US" b="0" i="0" dirty="0">
+                <a:solidFill>
+                  <a:srgbClr val="003B4F"/>
+                </a:solidFill>
+                <a:effectLst/>
+                <a:latin typeface="SFMono-Regular"/>
+              </a:rPr>
+              <a:t> </a:t>
+            </a:r>
+          </a:p>
+          <a:p>
+            <a:r>
+              <a:rPr lang="en-US" b="0" i="0" dirty="0">
+                <a:solidFill>
+                  <a:srgbClr val="5E5E5E"/>
+                </a:solidFill>
+                <a:effectLst/>
+                <a:latin typeface="SFMono-Regular"/>
+              </a:rPr>
+              <a:t># After completion, check performance</a:t>
+            </a:r>
+            <a:r>
+              <a:rPr lang="en-US" b="0" i="0" dirty="0">
+                <a:solidFill>
+                  <a:srgbClr val="003B4F"/>
+                </a:solidFill>
+                <a:effectLst/>
+                <a:latin typeface="SFMono-Regular"/>
+              </a:rPr>
+              <a:t> </a:t>
+            </a:r>
+          </a:p>
+          <a:p>
+            <a:r>
+              <a:rPr lang="en-US" b="0" i="0" dirty="0" err="1">
+                <a:solidFill>
+                  <a:srgbClr val="003B4F"/>
+                </a:solidFill>
+                <a:effectLst/>
+                <a:latin typeface="SFMono-Regular"/>
+              </a:rPr>
+              <a:t>bjobs</a:t>
+            </a:r>
+            <a:r>
+              <a:rPr lang="en-US" b="0" i="0" dirty="0">
+                <a:solidFill>
+                  <a:srgbClr val="003B4F"/>
+                </a:solidFill>
+                <a:effectLst/>
+                <a:latin typeface="SFMono-Regular"/>
+              </a:rPr>
+              <a:t> </a:t>
+            </a:r>
+            <a:r>
+              <a:rPr lang="en-US" b="0" i="0" dirty="0">
+                <a:solidFill>
+                  <a:srgbClr val="657422"/>
+                </a:solidFill>
+                <a:effectLst/>
+                <a:latin typeface="SFMono-Regular"/>
+              </a:rPr>
+              <a:t>-l</a:t>
+            </a:r>
+            <a:r>
+              <a:rPr lang="en-US" b="0" i="0" dirty="0">
+                <a:solidFill>
+                  <a:srgbClr val="003B4F"/>
+                </a:solidFill>
+                <a:effectLst/>
+                <a:latin typeface="SFMono-Regular"/>
+              </a:rPr>
+              <a:t> JOBID </a:t>
+            </a:r>
+            <a:r>
+              <a:rPr lang="en-US" b="0" i="0" dirty="0">
+                <a:solidFill>
+                  <a:srgbClr val="5E5E5E"/>
+                </a:solidFill>
+                <a:effectLst/>
+                <a:latin typeface="SFMono-Regular"/>
+              </a:rPr>
+              <a:t>&gt;</a:t>
+            </a:r>
+            <a:r>
+              <a:rPr lang="en-US" b="0" i="0" dirty="0">
+                <a:solidFill>
+                  <a:srgbClr val="003B4F"/>
+                </a:solidFill>
+                <a:effectLst/>
+                <a:latin typeface="SFMono-Regular"/>
+              </a:rPr>
+              <a:t> </a:t>
+            </a:r>
+            <a:r>
+              <a:rPr lang="en-US" b="0" i="0" dirty="0" err="1">
+                <a:solidFill>
+                  <a:srgbClr val="003B4F"/>
+                </a:solidFill>
+                <a:effectLst/>
+                <a:latin typeface="SFMono-Regular"/>
+              </a:rPr>
+              <a:t>job_analysis.txt</a:t>
+            </a:r>
+            <a:r>
+              <a:rPr lang="en-US" b="0" i="0" dirty="0">
+                <a:solidFill>
+                  <a:srgbClr val="003B4F"/>
+                </a:solidFill>
+                <a:effectLst/>
+                <a:latin typeface="SFMono-Regular"/>
+              </a:rPr>
+              <a:t> </a:t>
+            </a:r>
+          </a:p>
+          <a:p>
+            <a:r>
+              <a:rPr lang="en-US" b="0" i="0" dirty="0">
+                <a:solidFill>
+                  <a:srgbClr val="5E5E5E"/>
+                </a:solidFill>
+                <a:effectLst/>
+                <a:latin typeface="SFMono-Regular"/>
+              </a:rPr>
+              <a:t># Look at the output</a:t>
+            </a:r>
+            <a:r>
+              <a:rPr lang="en-US" b="0" i="0" dirty="0">
+                <a:solidFill>
+                  <a:srgbClr val="003B4F"/>
+                </a:solidFill>
+                <a:effectLst/>
+                <a:latin typeface="SFMono-Regular"/>
+              </a:rPr>
+              <a:t> </a:t>
+            </a:r>
+            <a:r>
+              <a:rPr lang="en-US" b="0" i="0" dirty="0">
+                <a:solidFill>
+                  <a:srgbClr val="4758AB"/>
+                </a:solidFill>
+                <a:effectLst/>
+                <a:latin typeface="SFMono-Regular"/>
+              </a:rPr>
+              <a:t>less</a:t>
+            </a:r>
+            <a:r>
+              <a:rPr lang="en-US" b="0" i="0" dirty="0">
+                <a:solidFill>
+                  <a:srgbClr val="003B4F"/>
+                </a:solidFill>
+                <a:effectLst/>
+                <a:latin typeface="SFMono-Regular"/>
+              </a:rPr>
+              <a:t> </a:t>
+            </a:r>
+            <a:r>
+              <a:rPr lang="en-US" b="0" i="0" dirty="0" err="1">
+                <a:solidFill>
+                  <a:srgbClr val="003B4F"/>
+                </a:solidFill>
+                <a:effectLst/>
+                <a:latin typeface="SFMono-Regular"/>
+              </a:rPr>
+              <a:t>job_analysis.txt</a:t>
+            </a:r>
+            <a:endParaRPr lang="en-US" dirty="0"/>
+          </a:p>
+        </p:txBody>
+      </p:sp>
+      <p:sp>
+        <p:nvSpPr>
+          <p:cNvPr id="7" name="Title 1">
+            <a:extLst>
+              <a:ext uri="{FF2B5EF4-FFF2-40B4-BE49-F238E27FC236}">
+                <a16:creationId xmlns:a16="http://schemas.microsoft.com/office/drawing/2014/main" id="{A6235CDC-EE1E-94B5-0325-9BBB7D9272B7}"/>
+              </a:ext>
+            </a:extLst>
+          </p:cNvPr>
+          <p:cNvSpPr txBox="1">
+            <a:spLocks/>
+          </p:cNvSpPr>
+          <p:nvPr/>
+        </p:nvSpPr>
+        <p:spPr>
+          <a:xfrm>
+            <a:off x="990600" y="517525"/>
+            <a:ext cx="10515600" cy="1325563"/>
+          </a:xfrm>
+          <a:prstGeom prst="rect">
+            <a:avLst/>
+          </a:prstGeom>
+        </p:spPr>
+        <p:txBody>
+          <a:bodyPr vert="horz" lIns="91440" tIns="45720" rIns="91440" bIns="45720" rtlCol="0" anchor="ctr">
+            <a:normAutofit/>
+          </a:bodyPr>
+          <a:lstStyle>
+            <a:lvl1pPr algn="l" defTabSz="914400" rtl="0" eaLnBrk="1" latinLnBrk="0" hangingPunct="1">
+              <a:lnSpc>
+                <a:spcPct val="90000"/>
+              </a:lnSpc>
+              <a:spcBef>
+                <a:spcPct val="0"/>
+              </a:spcBef>
+              <a:buNone/>
+              <a:defRPr sz="4400" kern="1200">
+                <a:solidFill>
+                  <a:schemeClr val="tx1"/>
+                </a:solidFill>
+                <a:latin typeface="+mj-lt"/>
+                <a:ea typeface="+mj-ea"/>
+                <a:cs typeface="+mj-cs"/>
+              </a:defRPr>
+            </a:lvl1pPr>
+          </a:lstStyle>
+          <a:p>
+            <a:r>
+              <a:rPr lang="en-US" b="1" dirty="0"/>
+              <a:t>Analyzing a Job</a:t>
+            </a:r>
+          </a:p>
+        </p:txBody>
+      </p:sp>
+      <p:pic>
+        <p:nvPicPr>
+          <p:cNvPr id="8" name="Picture 6" descr="coding Symbol mark in filled style 47628836 Vector Art at Vecteezy">
+            <a:extLst>
+              <a:ext uri="{FF2B5EF4-FFF2-40B4-BE49-F238E27FC236}">
+                <a16:creationId xmlns:a16="http://schemas.microsoft.com/office/drawing/2014/main" id="{2BF86E23-7D18-32E7-C0EE-D15E80F66D1C}"/>
+              </a:ext>
+            </a:extLst>
+          </p:cNvPr>
+          <p:cNvPicPr>
+            <a:picLocks noChangeAspect="1" noChangeArrowheads="1"/>
+          </p:cNvPicPr>
+          <p:nvPr/>
+        </p:nvPicPr>
+        <p:blipFill>
+          <a:blip r:embed="rId3">
+            <a:duotone>
+              <a:prstClr val="black"/>
+              <a:schemeClr val="accent4">
+                <a:tint val="45000"/>
+                <a:satMod val="400000"/>
+              </a:schemeClr>
+            </a:duotone>
+            <a:extLst>
+              <a:ext uri="{28A0092B-C50C-407E-A947-70E740481C1C}">
+                <a14:useLocalDpi xmlns:a14="http://schemas.microsoft.com/office/drawing/2010/main" val="0"/>
+              </a:ext>
+            </a:extLst>
+          </a:blip>
+          <a:srcRect/>
+          <a:stretch>
+            <a:fillRect/>
+          </a:stretch>
+        </p:blipFill>
+        <p:spPr bwMode="auto">
+          <a:xfrm>
+            <a:off x="4917440" y="626429"/>
+            <a:ext cx="904240" cy="904240"/>
+          </a:xfrm>
+          <a:prstGeom prst="rect">
+            <a:avLst/>
+          </a:prstGeom>
+          <a:noFill/>
+          <a:extLst>
+            <a:ext uri="{909E8E84-426E-40DD-AFC4-6F175D3DCCD1}">
+              <a14:hiddenFill xmlns:a14="http://schemas.microsoft.com/office/drawing/2010/main">
+                <a:solidFill>
+                  <a:srgbClr val="FFFFFF"/>
+                </a:solidFill>
+              </a14:hiddenFill>
+            </a:ext>
+          </a:extLst>
+        </p:spPr>
+      </p:pic>
+    </p:spTree>
+    <p:extLst>
+      <p:ext uri="{BB962C8B-B14F-4D97-AF65-F5344CB8AC3E}">
+        <p14:creationId xmlns:p14="http://schemas.microsoft.com/office/powerpoint/2010/main" val="1529687703"/>
       </p:ext>
     </p:extLst>
   </p:cSld>

</xml_diff>